<commit_message>
Add hydronet_generator.py: generates 14-slide HydroNet PPTX presentation
Agent-Logs-Url: https://github.com/abumdselim/ChtCisco/sessions/5756edd0-580e-4749-8bfb-46d6d0e1f919

Co-authored-by: abumdselim <190179079+abumdselim@users.noreply.github.com>
</commit_message>
<xml_diff>
--- a/HydroNet_Chittagong_Resilience_Final.pptx
+++ b/HydroNet_Chittagong_Resilience_Final.pptx
@@ -7864,7 +7864,7 @@
                   <a:srgbClr val="2D3D4F"/>
                 </a:solidFill>
               </a:rPr>
-              <a:t>ID: 0242210005048</a:t>
+              <a:t>ID: 2103910202114</a:t>
             </a:r>
           </a:p>
           <a:p>
@@ -7986,7 +7986,7 @@
                   <a:srgbClr val="2D3D4F"/>
                 </a:solidFill>
               </a:rPr>
-              <a:t>ID: 0242210005051</a:t>
+              <a:t>ID: 0222320005101088</a:t>
             </a:r>
           </a:p>
           <a:p>
@@ -8108,7 +8108,7 @@
                   <a:srgbClr val="2D3D4F"/>
                 </a:solidFill>
               </a:rPr>
-              <a:t>ID: 0242210005055</a:t>
+              <a:t>ID: 0222220005101143</a:t>
             </a:r>
           </a:p>
           <a:p>

</xml_diff>